<commit_message>
feat: add high-fidelity browser PowerPoint renderer
</commit_message>
<xml_diff>
--- a/scripts/ooxml-conformance/chart-deck.pptx
+++ b/scripts/ooxml-conformance/chart-deck.pptx
@@ -1762,6 +1762,30 @@
           </a:ln>
         </p:spPr>
       </p:pic>
+      <p:pic>
+        <p:nvPicPr>
+          <p:cNvPr id="53" name="Plain swatch"/>
+          <p:cNvPicPr>
+            <a:picLocks noChangeAspect="1"/>
+          </p:cNvPicPr>
+          <p:nvPr/>
+        </p:nvPicPr>
+        <p:blipFill>
+          <a:blip r:embed="rId2"/>
+          <a:stretch>
+            <a:fillRect/>
+          </a:stretch>
+        </p:blipFill>
+        <p:spPr>
+          <a:xfrm>
+            <a:off x="6300000" y="4428000"/>
+            <a:ext cx="1080000" cy="720000"/>
+          </a:xfrm>
+          <a:prstGeom prst="rect">
+            <a:avLst/>
+          </a:prstGeom>
+        </p:spPr>
+      </p:pic>
       <p:cxnSp>
         <p:nvCxnSpPr>
           <p:cNvPr id="47" name="Arrow"/>
@@ -1827,6 +1851,84 @@
               <a:alpha val="60000"/>
             </a:srgbClr>
           </a:solidFill>
+        </p:spPr>
+      </p:sp>
+      <p:sp>
+        <p:nvSpPr>
+          <p:cNvPr id="51" name="Custom geometry"/>
+          <p:cNvSpPr/>
+          <p:nvPr/>
+        </p:nvSpPr>
+        <p:spPr>
+          <a:xfrm>
+            <a:off x="6300000" y="1512000"/>
+            <a:ext cx="1800000" cy="1080000"/>
+          </a:xfrm>
+          <a:custGeom>
+            <a:avLst/>
+            <a:gdLst/>
+            <a:pathLst>
+              <a:path>
+                <a:moveTo>
+                  <a:pt x="10800" y="0"/>
+                </a:moveTo>
+                <a:lnTo>
+                  <a:pt x="21600" y="21600"/>
+                </a:lnTo>
+                <a:lnTo>
+                  <a:pt x="0" y="21600"/>
+                </a:lnTo>
+                <a:close/>
+              </a:path>
+            </a:pathLst>
+          </a:custGeom>
+          <a:solidFill>
+            <a:srgbClr val="E8F0FE"/>
+          </a:solidFill>
+          <a:ln w="19050">
+            <a:solidFill>
+              <a:srgbClr val="1F2328"/>
+            </a:solidFill>
+          </a:ln>
+        </p:spPr>
+      </p:sp>
+      <p:sp>
+        <p:nvSpPr>
+          <p:cNvPr id="52" name="Custom geometry sized"/>
+          <p:cNvSpPr/>
+          <p:nvPr/>
+        </p:nvSpPr>
+        <p:spPr>
+          <a:xfrm>
+            <a:off x="6300000" y="2664000"/>
+            <a:ext cx="1800000" cy="1080000"/>
+          </a:xfrm>
+          <a:custGeom>
+            <a:avLst/>
+            <a:gdLst/>
+            <a:pathLst>
+              <a:path w="21600" h="21600">
+                <a:moveTo>
+                  <a:pt x="10800" y="0"/>
+                </a:moveTo>
+                <a:lnTo>
+                  <a:pt x="21600" y="21600"/>
+                </a:lnTo>
+                <a:lnTo>
+                  <a:pt x="0" y="21600"/>
+                </a:lnTo>
+                <a:close/>
+              </a:path>
+            </a:pathLst>
+          </a:custGeom>
+          <a:solidFill>
+            <a:srgbClr val="FFF4E5"/>
+          </a:solidFill>
+          <a:ln w="19050">
+            <a:solidFill>
+              <a:srgbClr val="1F2328"/>
+            </a:solidFill>
+          </a:ln>
         </p:spPr>
       </p:sp>
       <p:sp>

</xml_diff>